<commit_message>
Salva o Slides_novos.pptx pelo PowerPoint
Co-Authored-By: Claude Opus 5 <noreply@anthropic.com>
Claude-Session: https://claude.ai/code/session_01DSGyhEEgcNw6yrti8q4y4H
</commit_message>
<xml_diff>
--- a/Final/Slides_novos.pptx
+++ b/Final/Slides_novos.pptx
@@ -22105,7 +22105,7 @@
           <a:noFill/>
         </p:spPr>
         <p:txBody>
-          <a:bodyPr wrap="square" lIns="0" rIns="0" tIns="0" bIns="0" anchor="t">
+          <a:bodyPr wrap="square" lIns="0" tIns="0" rIns="0" bIns="0" anchor="t">
             <a:spAutoFit/>
           </a:bodyPr>
           <a:lstStyle/>
@@ -22142,7 +22142,7 @@
           <p:nvPr/>
         </p:nvPicPr>
         <p:blipFill>
-          <a:blip r:embed="rId4"/>
+          <a:blip r:embed="rId3"/>
           <a:stretch>
             <a:fillRect/>
           </a:stretch>
@@ -22174,7 +22174,7 @@
           <a:noFill/>
         </p:spPr>
         <p:txBody>
-          <a:bodyPr wrap="square" lIns="0" rIns="0" tIns="0" bIns="0" anchor="t">
+          <a:bodyPr wrap="square" lIns="0" tIns="0" rIns="0" bIns="0" anchor="t">
             <a:spAutoFit/>
           </a:bodyPr>
           <a:lstStyle/>
@@ -22211,7 +22211,7 @@
           <p:nvPr/>
         </p:nvPicPr>
         <p:blipFill>
-          <a:blip r:embed="rId5"/>
+          <a:blip r:embed="rId4"/>
           <a:stretch>
             <a:fillRect/>
           </a:stretch>
@@ -22285,7 +22285,9 @@
         <p:txBody>
           <a:bodyPr rtlCol="0" anchor="ctr"/>
           <a:lstStyle/>
-          <a:p/>
+          <a:p>
+            <a:endParaRPr/>
+          </a:p>
         </p:txBody>
       </p:sp>
       <p:sp>
@@ -22305,7 +22307,7 @@
           <a:noFill/>
         </p:spPr>
         <p:txBody>
-          <a:bodyPr wrap="square" lIns="0" rIns="0" tIns="0" bIns="0" anchor="ctr">
+          <a:bodyPr wrap="square" lIns="0" tIns="0" rIns="0" bIns="0" anchor="ctr">
             <a:spAutoFit/>
           </a:bodyPr>
           <a:lstStyle/>
@@ -22350,7 +22352,7 @@
           <a:noFill/>
         </p:spPr>
         <p:txBody>
-          <a:bodyPr wrap="none" lIns="0" rIns="0" tIns="0" bIns="0" anchor="ctr">
+          <a:bodyPr wrap="none" lIns="0" tIns="0" rIns="0" bIns="0" anchor="ctr">
             <a:spAutoFit/>
           </a:bodyPr>
           <a:lstStyle/>
@@ -22395,7 +22397,7 @@
           <a:noFill/>
         </p:spPr>
         <p:txBody>
-          <a:bodyPr wrap="none" lIns="0" rIns="0" tIns="0" bIns="0" anchor="ctr">
+          <a:bodyPr wrap="none" lIns="0" tIns="0" rIns="0" bIns="0" anchor="ctr">
             <a:spAutoFit/>
           </a:bodyPr>
           <a:lstStyle/>
@@ -22482,7 +22484,9 @@
         <p:txBody>
           <a:bodyPr rtlCol="0" anchor="ctr"/>
           <a:lstStyle/>
-          <a:p/>
+          <a:p>
+            <a:endParaRPr/>
+          </a:p>
         </p:txBody>
       </p:sp>
       <p:sp>
@@ -22502,7 +22506,7 @@
           <a:noFill/>
         </p:spPr>
         <p:txBody>
-          <a:bodyPr wrap="square" lIns="0" rIns="0" tIns="0" bIns="0" anchor="ctr">
+          <a:bodyPr wrap="square" lIns="0" tIns="0" rIns="0" bIns="0" anchor="ctr">
             <a:spAutoFit/>
           </a:bodyPr>
           <a:lstStyle/>
@@ -22547,7 +22551,7 @@
           <a:noFill/>
         </p:spPr>
         <p:txBody>
-          <a:bodyPr wrap="none" lIns="0" rIns="0" tIns="0" bIns="0" anchor="ctr">
+          <a:bodyPr wrap="none" lIns="0" tIns="0" rIns="0" bIns="0" anchor="ctr">
             <a:spAutoFit/>
           </a:bodyPr>
           <a:lstStyle/>
@@ -22592,7 +22596,7 @@
           <a:noFill/>
         </p:spPr>
         <p:txBody>
-          <a:bodyPr wrap="none" lIns="0" rIns="0" tIns="0" bIns="0" anchor="ctr">
+          <a:bodyPr wrap="none" lIns="0" tIns="0" rIns="0" bIns="0" anchor="ctr">
             <a:spAutoFit/>
           </a:bodyPr>
           <a:lstStyle/>
@@ -22679,7 +22683,9 @@
         <p:txBody>
           <a:bodyPr rtlCol="0" anchor="ctr"/>
           <a:lstStyle/>
-          <a:p/>
+          <a:p>
+            <a:endParaRPr/>
+          </a:p>
         </p:txBody>
       </p:sp>
       <p:sp>
@@ -22699,7 +22705,7 @@
           <a:noFill/>
         </p:spPr>
         <p:txBody>
-          <a:bodyPr wrap="square" lIns="0" rIns="0" tIns="0" bIns="0" anchor="ctr">
+          <a:bodyPr wrap="square" lIns="0" tIns="0" rIns="0" bIns="0" anchor="ctr">
             <a:spAutoFit/>
           </a:bodyPr>
           <a:lstStyle/>
@@ -22744,7 +22750,7 @@
           <a:noFill/>
         </p:spPr>
         <p:txBody>
-          <a:bodyPr wrap="none" lIns="0" rIns="0" tIns="0" bIns="0" anchor="ctr">
+          <a:bodyPr wrap="none" lIns="0" tIns="0" rIns="0" bIns="0" anchor="ctr">
             <a:spAutoFit/>
           </a:bodyPr>
           <a:lstStyle/>
@@ -22789,7 +22795,7 @@
           <a:noFill/>
         </p:spPr>
         <p:txBody>
-          <a:bodyPr wrap="none" lIns="0" rIns="0" tIns="0" bIns="0" anchor="ctr">
+          <a:bodyPr wrap="none" lIns="0" tIns="0" rIns="0" bIns="0" anchor="ctr">
             <a:spAutoFit/>
           </a:bodyPr>
           <a:lstStyle/>
@@ -22876,7 +22882,9 @@
         <p:txBody>
           <a:bodyPr rtlCol="0" anchor="ctr"/>
           <a:lstStyle/>
-          <a:p/>
+          <a:p>
+            <a:endParaRPr/>
+          </a:p>
         </p:txBody>
       </p:sp>
       <p:sp>
@@ -22896,7 +22904,7 @@
           <a:noFill/>
         </p:spPr>
         <p:txBody>
-          <a:bodyPr wrap="square" lIns="0" rIns="0" tIns="0" bIns="0" anchor="ctr">
+          <a:bodyPr wrap="square" lIns="0" tIns="0" rIns="0" bIns="0" anchor="ctr">
             <a:spAutoFit/>
           </a:bodyPr>
           <a:lstStyle/>
@@ -22941,7 +22949,7 @@
           <a:noFill/>
         </p:spPr>
         <p:txBody>
-          <a:bodyPr wrap="none" lIns="0" rIns="0" tIns="0" bIns="0" anchor="ctr">
+          <a:bodyPr wrap="none" lIns="0" tIns="0" rIns="0" bIns="0" anchor="ctr">
             <a:spAutoFit/>
           </a:bodyPr>
           <a:lstStyle/>
@@ -22986,7 +22994,7 @@
           <a:noFill/>
         </p:spPr>
         <p:txBody>
-          <a:bodyPr wrap="none" lIns="0" rIns="0" tIns="0" bIns="0" anchor="ctr">
+          <a:bodyPr wrap="none" lIns="0" tIns="0" rIns="0" bIns="0" anchor="ctr">
             <a:spAutoFit/>
           </a:bodyPr>
           <a:lstStyle/>

</xml_diff>